<commit_message>
chores: type in slides fixed
</commit_message>
<xml_diff>
--- a/reports/streamcab_presentation.pptx
+++ b/reports/streamcab_presentation.pptx
@@ -14990,7 +14990,7 @@
               <a:t>Rows:</a:t>
             </a:r>
             <a:r>
-              <a:rPr dirty="0" sz="1100" spc="220">
+              <a:rPr dirty="0" sz="1100" spc="225">
                 <a:solidFill>
                   <a:srgbClr val="22373A"/>
                 </a:solidFill>
@@ -15010,7 +15010,7 @@
               <a:t>1642819405</a:t>
             </a:r>
             <a:r>
-              <a:rPr dirty="0" sz="1100" spc="459" b="1">
+              <a:rPr dirty="0" sz="1100" spc="470" b="1">
                 <a:solidFill>
                   <a:srgbClr val="22373A"/>
                 </a:solidFill>
@@ -15040,17 +15040,17 @@
               <a:t> </a:t>
             </a:r>
             <a:r>
-              <a:rPr dirty="0" sz="1100" spc="10">
-                <a:solidFill>
-                  <a:srgbClr val="22373A"/>
-                </a:solidFill>
-                <a:latin typeface="Calibri"/>
-                <a:cs typeface="Calibri"/>
-              </a:rPr>
-              <a:t>16</a:t>
-            </a:r>
-            <a:r>
-              <a:rPr dirty="0" sz="1100" spc="105">
+              <a:rPr dirty="0" sz="1100">
+                <a:solidFill>
+                  <a:srgbClr val="22373A"/>
+                </a:solidFill>
+                <a:latin typeface="Calibri"/>
+                <a:cs typeface="Calibri"/>
+              </a:rPr>
+              <a:t>16̇</a:t>
+            </a:r>
+            <a:r>
+              <a:rPr dirty="0" sz="1100" spc="110">
                 <a:solidFill>
                   <a:srgbClr val="22373A"/>
                 </a:solidFill>

</xml_diff>